<commit_message>
Mid week demo uploads
Scripts and powerpoint
</commit_message>
<xml_diff>
--- a/Docs/Mid Demo/Mid Project Demo PP.pptx
+++ b/Docs/Mid Demo/Mid Project Demo PP.pptx
@@ -5,7 +5,7 @@
     <p:sldMasterId id="2147483696" r:id="rId1"/>
   </p:sldMasterIdLst>
   <p:notesMasterIdLst>
-    <p:notesMasterId r:id="rId14"/>
+    <p:notesMasterId r:id="rId13"/>
   </p:notesMasterIdLst>
   <p:sldIdLst>
     <p:sldId id="256" r:id="rId2"/>
@@ -19,7 +19,6 @@
     <p:sldId id="273" r:id="rId10"/>
     <p:sldId id="274" r:id="rId11"/>
     <p:sldId id="261" r:id="rId12"/>
-    <p:sldId id="262" r:id="rId13"/>
   </p:sldIdLst>
   <p:sldSz cx="12192000" cy="6858000"/>
   <p:notesSz cx="6858000" cy="9144000"/>
@@ -118,6 +117,11 @@
       </a:defRPr>
     </a:lvl9pPr>
   </p:defaultTextStyle>
+  <p:extLst>
+    <p:ext uri="{EFAFB233-063F-42B5-8137-9DF3F51BA10A}">
+      <p15:sldGuideLst xmlns:p15="http://schemas.microsoft.com/office/powerpoint/2012/main"/>
+    </p:ext>
+  </p:extLst>
 </p:presentation>
 </file>
 
@@ -203,7 +207,7 @@
           <a:p>
             <a:fld id="{D227C833-5B6B-4331-A5F5-DFDF55383D64}" type="datetimeFigureOut">
               <a:rPr lang="en-GB" smtClean="0"/>
-              <a:t>09/03/2025</a:t>
+              <a:t>12/03/2025</a:t>
             </a:fld>
             <a:endParaRPr lang="en-GB"/>
           </a:p>
@@ -686,7 +690,7 @@
           <a:p>
             <a:fld id="{F3EB8E90-470A-443D-860C-FCE320DEF9A2}" type="datetimeFigureOut">
               <a:rPr lang="en-GB" smtClean="0"/>
-              <a:t>09/03/2025</a:t>
+              <a:t>12/03/2025</a:t>
             </a:fld>
             <a:endParaRPr lang="en-GB"/>
           </a:p>
@@ -856,7 +860,7 @@
           <a:p>
             <a:fld id="{F3EB8E90-470A-443D-860C-FCE320DEF9A2}" type="datetimeFigureOut">
               <a:rPr lang="en-GB" smtClean="0"/>
-              <a:t>09/03/2025</a:t>
+              <a:t>12/03/2025</a:t>
             </a:fld>
             <a:endParaRPr lang="en-GB"/>
           </a:p>
@@ -1036,7 +1040,7 @@
           <a:p>
             <a:fld id="{F3EB8E90-470A-443D-860C-FCE320DEF9A2}" type="datetimeFigureOut">
               <a:rPr lang="en-GB" smtClean="0"/>
-              <a:t>09/03/2025</a:t>
+              <a:t>12/03/2025</a:t>
             </a:fld>
             <a:endParaRPr lang="en-GB"/>
           </a:p>
@@ -1206,7 +1210,7 @@
           <a:p>
             <a:fld id="{F3EB8E90-470A-443D-860C-FCE320DEF9A2}" type="datetimeFigureOut">
               <a:rPr lang="en-GB" smtClean="0"/>
-              <a:t>09/03/2025</a:t>
+              <a:t>12/03/2025</a:t>
             </a:fld>
             <a:endParaRPr lang="en-GB"/>
           </a:p>
@@ -1452,7 +1456,7 @@
           <a:p>
             <a:fld id="{F3EB8E90-470A-443D-860C-FCE320DEF9A2}" type="datetimeFigureOut">
               <a:rPr lang="en-GB" smtClean="0"/>
-              <a:t>09/03/2025</a:t>
+              <a:t>12/03/2025</a:t>
             </a:fld>
             <a:endParaRPr lang="en-GB"/>
           </a:p>
@@ -1684,7 +1688,7 @@
           <a:p>
             <a:fld id="{F3EB8E90-470A-443D-860C-FCE320DEF9A2}" type="datetimeFigureOut">
               <a:rPr lang="en-GB" smtClean="0"/>
-              <a:t>09/03/2025</a:t>
+              <a:t>12/03/2025</a:t>
             </a:fld>
             <a:endParaRPr lang="en-GB"/>
           </a:p>
@@ -2051,7 +2055,7 @@
           <a:p>
             <a:fld id="{F3EB8E90-470A-443D-860C-FCE320DEF9A2}" type="datetimeFigureOut">
               <a:rPr lang="en-GB" smtClean="0"/>
-              <a:t>09/03/2025</a:t>
+              <a:t>12/03/2025</a:t>
             </a:fld>
             <a:endParaRPr lang="en-GB"/>
           </a:p>
@@ -2169,7 +2173,7 @@
           <a:p>
             <a:fld id="{F3EB8E90-470A-443D-860C-FCE320DEF9A2}" type="datetimeFigureOut">
               <a:rPr lang="en-GB" smtClean="0"/>
-              <a:t>09/03/2025</a:t>
+              <a:t>12/03/2025</a:t>
             </a:fld>
             <a:endParaRPr lang="en-GB"/>
           </a:p>
@@ -2264,7 +2268,7 @@
           <a:p>
             <a:fld id="{F3EB8E90-470A-443D-860C-FCE320DEF9A2}" type="datetimeFigureOut">
               <a:rPr lang="en-GB" smtClean="0"/>
-              <a:t>09/03/2025</a:t>
+              <a:t>12/03/2025</a:t>
             </a:fld>
             <a:endParaRPr lang="en-GB"/>
           </a:p>
@@ -2541,7 +2545,7 @@
           <a:p>
             <a:fld id="{F3EB8E90-470A-443D-860C-FCE320DEF9A2}" type="datetimeFigureOut">
               <a:rPr lang="en-GB" smtClean="0"/>
-              <a:t>09/03/2025</a:t>
+              <a:t>12/03/2025</a:t>
             </a:fld>
             <a:endParaRPr lang="en-GB"/>
           </a:p>
@@ -2798,7 +2802,7 @@
           <a:p>
             <a:fld id="{F3EB8E90-470A-443D-860C-FCE320DEF9A2}" type="datetimeFigureOut">
               <a:rPr lang="en-GB" smtClean="0"/>
-              <a:t>09/03/2025</a:t>
+              <a:t>12/03/2025</a:t>
             </a:fld>
             <a:endParaRPr lang="en-GB"/>
           </a:p>
@@ -3011,7 +3015,7 @@
           <a:p>
             <a:fld id="{F3EB8E90-470A-443D-860C-FCE320DEF9A2}" type="datetimeFigureOut">
               <a:rPr lang="en-GB" smtClean="0"/>
-              <a:t>09/03/2025</a:t>
+              <a:t>12/03/2025</a:t>
             </a:fld>
             <a:endParaRPr lang="en-GB"/>
           </a:p>
@@ -4058,17 +4062,6 @@
             <a:pPr algn="l"/>
             <a:endParaRPr lang="en-GB" sz="1700" dirty="0"/>
           </a:p>
-          <a:p>
-            <a:pPr algn="l"/>
-            <a:r>
-              <a:rPr lang="en-GB" sz="1700" dirty="0">
-                <a:solidFill>
-                  <a:srgbClr val="FF0000"/>
-                </a:solidFill>
-              </a:rPr>
-              <a:t>Red Notes = Tutorial Only / Fixes</a:t>
-            </a:r>
-          </a:p>
         </p:txBody>
       </p:sp>
     </p:spTree>
@@ -5196,24 +5189,65 @@
           <a:p>
             <a:r>
               <a:rPr lang="en-GB" sz="2600" dirty="0"/>
-              <a:t>Any opinions on the way I should progress in terms of objectives?</a:t>
-            </a:r>
-          </a:p>
-          <a:p>
-            <a:pPr lvl="3"/>
-            <a:r>
-              <a:rPr lang="en-GB" sz="2000" dirty="0"/>
-              <a:t>Balancing Marks Vs Fun Gameplay</a:t>
-            </a:r>
-          </a:p>
-          <a:p>
-            <a:pPr lvl="3"/>
-            <a:endParaRPr lang="en-GB" sz="2000" dirty="0"/>
+              <a:t>Any opinions on the way I should progress in terms of objectives? Here are my ideas-</a:t>
+            </a:r>
+          </a:p>
+          <a:p>
+            <a:pPr lvl="1"/>
+            <a:r>
+              <a:rPr lang="en-GB" sz="1800" b="1" dirty="0"/>
+              <a:t>A tower defence / base building game. </a:t>
+            </a:r>
+            <a:r>
+              <a:rPr lang="en-GB" sz="1800" dirty="0"/>
+              <a:t>The recover is equipped with tools to gather resources. You must acquire these resources to build defences for the lunar base, or the humans inside will be exposed to a pathogen etc. This allows for quite a range of technical aspects, sticks to the core idea of rover exploration to gather resources, and is more interesting than simple navigation.</a:t>
+            </a:r>
+          </a:p>
+          <a:p>
+            <a:pPr lvl="1"/>
+            <a:r>
+              <a:rPr lang="en-GB" sz="1800" b="1" dirty="0"/>
+              <a:t>Like battleships but with movement and unique weapons.</a:t>
+            </a:r>
+            <a:r>
+              <a:rPr lang="en-GB" sz="1800" dirty="0"/>
+              <a:t> Two rovers (equipped with weapons of some sort) must fire at the enemy, accounting for wind and terrain. This could also be quite technically challenging, and allows for the possibility of multiplayer, but I feel its straying away from the rover exploration idea.</a:t>
+            </a:r>
+          </a:p>
+          <a:p>
+            <a:pPr lvl="1"/>
+            <a:r>
+              <a:rPr lang="en-GB" sz="1800" b="1" dirty="0"/>
+              <a:t>An almost text adventure kind of game mixed with D&amp;D. </a:t>
+            </a:r>
+            <a:r>
+              <a:rPr lang="en-GB" sz="1800" dirty="0"/>
+              <a:t>You navigate to tiles, each one returning text within the UI or adding to a mission log. I feel whilst this keeps to the idea of rover exploration it’s on the less technical side and will involve more story writing than coding/design.</a:t>
+            </a:r>
+          </a:p>
+          <a:p>
+            <a:pPr lvl="2"/>
+            <a:r>
+              <a:rPr lang="en-GB" sz="1600" dirty="0"/>
+              <a:t>E.g. The rover discovers signs of life. What should it do? </a:t>
+            </a:r>
+            <a:r>
+              <a:rPr lang="en-GB" sz="1600" i="1" dirty="0"/>
+              <a:t>Follow Them / Go in the opposite direction</a:t>
+            </a:r>
+          </a:p>
+          <a:p>
+            <a:pPr lvl="2"/>
+            <a:endParaRPr lang="en-GB" sz="600" dirty="0"/>
+          </a:p>
+          <a:p>
+            <a:pPr lvl="2"/>
+            <a:endParaRPr lang="en-GB" sz="600" dirty="0"/>
           </a:p>
           <a:p>
             <a:r>
               <a:rPr lang="en-GB" sz="2600" dirty="0"/>
-              <a:t>Is mobile implementation too ambitious?</a:t>
+              <a:t>Is mobile implementation too ambitious? (this will depend on the next steps)</a:t>
             </a:r>
           </a:p>
           <a:p>
@@ -5228,155 +5262,6 @@
     <p:extLst>
       <p:ext uri="{BB962C8B-B14F-4D97-AF65-F5344CB8AC3E}">
         <p14:creationId xmlns:p14="http://schemas.microsoft.com/office/powerpoint/2010/main" val="2954930590"/>
-      </p:ext>
-    </p:extLst>
-  </p:cSld>
-  <p:clrMapOvr>
-    <a:masterClrMapping/>
-  </p:clrMapOvr>
-</p:sld>
-</file>
-
-<file path=ppt/slides/slide12.xml><?xml version="1.0" encoding="utf-8"?>
-<p:sld xmlns:a="http://schemas.openxmlformats.org/drawingml/2006/main" xmlns:r="http://schemas.openxmlformats.org/officeDocument/2006/relationships" xmlns:p="http://schemas.openxmlformats.org/presentationml/2006/main">
-  <p:cSld>
-    <p:spTree>
-      <p:nvGrpSpPr>
-        <p:cNvPr id="1" name=""/>
-        <p:cNvGrpSpPr/>
-        <p:nvPr/>
-      </p:nvGrpSpPr>
-      <p:grpSpPr>
-        <a:xfrm>
-          <a:off x="0" y="0"/>
-          <a:ext cx="0" cy="0"/>
-          <a:chOff x="0" y="0"/>
-          <a:chExt cx="0" cy="0"/>
-        </a:xfrm>
-      </p:grpSpPr>
-      <p:sp>
-        <p:nvSpPr>
-          <p:cNvPr id="2" name="Title 1">
-            <a:extLst>
-              <a:ext uri="{FF2B5EF4-FFF2-40B4-BE49-F238E27FC236}">
-                <a16:creationId xmlns:a16="http://schemas.microsoft.com/office/drawing/2014/main" id="{9F61B115-3C92-5FF9-0D93-40AC7CAFBDA9}"/>
-              </a:ext>
-            </a:extLst>
-          </p:cNvPr>
-          <p:cNvSpPr>
-            <a:spLocks noGrp="1"/>
-          </p:cNvSpPr>
-          <p:nvPr>
-            <p:ph type="title"/>
-          </p:nvPr>
-        </p:nvSpPr>
-        <p:spPr/>
-        <p:txBody>
-          <a:bodyPr/>
-          <a:lstStyle/>
-          <a:p>
-            <a:r>
-              <a:rPr lang="en-GB" dirty="0"/>
-              <a:t>End</a:t>
-            </a:r>
-          </a:p>
-        </p:txBody>
-      </p:sp>
-      <p:sp>
-        <p:nvSpPr>
-          <p:cNvPr id="3" name="Content Placeholder 2">
-            <a:extLst>
-              <a:ext uri="{FF2B5EF4-FFF2-40B4-BE49-F238E27FC236}">
-                <a16:creationId xmlns:a16="http://schemas.microsoft.com/office/drawing/2014/main" id="{BDF6E152-28C8-6339-8D8D-697EB824E47B}"/>
-              </a:ext>
-            </a:extLst>
-          </p:cNvPr>
-          <p:cNvSpPr>
-            <a:spLocks noGrp="1"/>
-          </p:cNvSpPr>
-          <p:nvPr>
-            <p:ph idx="1"/>
-          </p:nvPr>
-        </p:nvSpPr>
-        <p:spPr/>
-        <p:txBody>
-          <a:bodyPr/>
-          <a:lstStyle/>
-          <a:p>
-            <a:r>
-              <a:rPr lang="en-GB" dirty="0">
-                <a:solidFill>
-                  <a:srgbClr val="FF0000"/>
-                </a:solidFill>
-              </a:rPr>
-              <a:t>Things to do before mid demo on Thursday-</a:t>
-            </a:r>
-          </a:p>
-          <a:p>
-            <a:r>
-              <a:rPr lang="en-GB" dirty="0">
-                <a:solidFill>
-                  <a:srgbClr val="FF0000"/>
-                </a:solidFill>
-              </a:rPr>
-              <a:t>Add git link and demo link</a:t>
-            </a:r>
-          </a:p>
-          <a:p>
-            <a:r>
-              <a:rPr lang="en-GB" dirty="0">
-                <a:solidFill>
-                  <a:srgbClr val="FF0000"/>
-                </a:solidFill>
-              </a:rPr>
-              <a:t>Fix canvases in Unity</a:t>
-            </a:r>
-          </a:p>
-          <a:p>
-            <a:r>
-              <a:rPr lang="en-GB" dirty="0">
-                <a:solidFill>
-                  <a:srgbClr val="FF0000"/>
-                </a:solidFill>
-              </a:rPr>
-              <a:t>Add a win panel that activates in Unity</a:t>
-            </a:r>
-          </a:p>
-          <a:p>
-            <a:r>
-              <a:rPr lang="en-GB" dirty="0">
-                <a:solidFill>
-                  <a:srgbClr val="FF0000"/>
-                </a:solidFill>
-              </a:rPr>
-              <a:t>Add reasons why choices made</a:t>
-            </a:r>
-          </a:p>
-          <a:p>
-            <a:pPr lvl="1"/>
-            <a:endParaRPr lang="en-GB" dirty="0">
-              <a:solidFill>
-                <a:srgbClr val="FF0000"/>
-              </a:solidFill>
-            </a:endParaRPr>
-          </a:p>
-          <a:p>
-            <a:endParaRPr lang="en-GB" dirty="0">
-              <a:solidFill>
-                <a:srgbClr val="FF0000"/>
-              </a:solidFill>
-            </a:endParaRPr>
-          </a:p>
-          <a:p>
-            <a:pPr lvl="1"/>
-            <a:endParaRPr lang="en-GB" dirty="0"/>
-          </a:p>
-        </p:txBody>
-      </p:sp>
-    </p:spTree>
-    <p:extLst>
-      <p:ext uri="{BB962C8B-B14F-4D97-AF65-F5344CB8AC3E}">
-        <p14:creationId xmlns:p14="http://schemas.microsoft.com/office/powerpoint/2010/main" val="1673092455"/>
       </p:ext>
     </p:extLst>
   </p:cSld>
@@ -5897,13 +5782,34 @@
               <a:buNone/>
             </a:pPr>
             <a:r>
-              <a:rPr lang="en-GB" sz="2000" i="1" dirty="0">
-                <a:solidFill>
-                  <a:srgbClr val="FF0000"/>
-                </a:solidFill>
+              <a:rPr lang="en-US" sz="1400" dirty="0" err="1">
+                <a:hlinkClick r:id="rId2"/>
               </a:rPr>
-              <a:t>GitHub Link Here</a:t>
-            </a:r>
+              <a:t>TurtleandFrog</a:t>
+            </a:r>
+            <a:r>
+              <a:rPr lang="en-US" sz="1400" dirty="0">
+                <a:hlinkClick r:id="rId2"/>
+              </a:rPr>
+              <a:t>/MMP-</a:t>
+            </a:r>
+            <a:r>
+              <a:rPr lang="en-US" sz="1400" dirty="0" err="1">
+                <a:hlinkClick r:id="rId2"/>
+              </a:rPr>
+              <a:t>RoverGame</a:t>
+            </a:r>
+            <a:r>
+              <a:rPr lang="en-US" sz="1400" dirty="0">
+                <a:hlinkClick r:id="rId2"/>
+              </a:rPr>
+              <a:t>: CS39440 Major Project</a:t>
+            </a:r>
+            <a:endParaRPr lang="en-GB" sz="2000" i="1" dirty="0">
+              <a:solidFill>
+                <a:srgbClr val="FF0000"/>
+              </a:solidFill>
+            </a:endParaRPr>
           </a:p>
         </p:txBody>
       </p:sp>
@@ -7517,27 +7423,13 @@
         </p:spPr>
         <p:txBody>
           <a:bodyPr anchor="t" anchorCtr="0">
-            <a:normAutofit/>
+            <a:normAutofit fontScale="92500" lnSpcReduction="20000"/>
           </a:bodyPr>
           <a:lstStyle/>
           <a:p>
             <a:r>
-              <a:rPr lang="en-GB" sz="2600" b="1" dirty="0">
-                <a:solidFill>
-                  <a:srgbClr val="FF0000"/>
-                </a:solidFill>
-              </a:rPr>
-              <a:t>UI Canvases are currently broken :/</a:t>
-            </a:r>
-          </a:p>
-          <a:p>
-            <a:r>
-              <a:rPr lang="en-GB" sz="2600" b="1" dirty="0">
-                <a:solidFill>
-                  <a:srgbClr val="FF0000"/>
-                </a:solidFill>
-              </a:rPr>
-              <a:t>Switching resolution from second monitor to laptop for demo caused this, would have been an issue later regardless. Fix is to set a fixed resolution within the scene player then manually adjust UI.</a:t>
+              <a:rPr lang="en-GB" sz="2600" dirty="0"/>
+              <a:t>Instead of explaining there’s a demo. Whilst there are several missing features (and one bug by my count) this should provide a basic introduction to the game.</a:t>
             </a:r>
           </a:p>
           <a:p>
@@ -7545,18 +7437,26 @@
           </a:p>
           <a:p>
             <a:r>
-              <a:rPr lang="en-GB" sz="2600" dirty="0"/>
-              <a:t>All assets are merely placeholder assets from the unity asset store/ itch.io</a:t>
-            </a:r>
-          </a:p>
-          <a:p>
-            <a:r>
-              <a:rPr lang="en-GB" sz="2600" i="1" dirty="0">
-                <a:solidFill>
-                  <a:srgbClr val="FF0000"/>
-                </a:solidFill>
-              </a:rPr>
-              <a:t>Demo Link Here</a:t>
+              <a:rPr lang="en-GB" sz="2600" b="1" dirty="0"/>
+              <a:t>(Might be worth undertaking the demo at the end as my laptop has occasionally blue-screened upon launching unity.)</a:t>
+            </a:r>
+          </a:p>
+          <a:p>
+            <a:endParaRPr lang="en-GB" sz="2600" dirty="0"/>
+          </a:p>
+          <a:p>
+            <a:endParaRPr lang="en-GB" sz="2600" dirty="0"/>
+          </a:p>
+          <a:p>
+            <a:endParaRPr lang="en-GB" sz="2600" dirty="0"/>
+          </a:p>
+          <a:p>
+            <a:endParaRPr lang="en-GB" sz="2600" dirty="0"/>
+          </a:p>
+          <a:p>
+            <a:r>
+              <a:rPr lang="en-GB" sz="2600" i="1" dirty="0"/>
+              <a:t>All assets are merely placeholder assets from the unity asset store/ itch.io. Whilst not referenced here they will be in my final report.</a:t>
             </a:r>
           </a:p>
         </p:txBody>
@@ -8182,7 +8082,7 @@
           <a:p>
             <a:r>
               <a:rPr lang="en-GB" sz="2000" dirty="0"/>
-              <a:t>Unused A* algorithm (Perhaps implemented later)</a:t>
+              <a:t>Unused A* algorithm (Perhaps implemented later) Heavily adapted from various sources on the internet (and buggy for hexes)</a:t>
             </a:r>
           </a:p>
           <a:p>
@@ -8691,10 +8591,10 @@
             </a:r>
           </a:p>
           <a:p>
-            <a:pPr lvl="2"/>
+            <a:pPr lvl="1"/>
             <a:r>
               <a:rPr lang="en-GB" sz="2200" dirty="0"/>
-              <a:t>May massively impact gameplay style. XCOM style encounters? Purely Transport &amp; retrieval? More puzzle based? Minigames (reach objective do minigame?)</a:t>
+              <a:t>I’ll comment on these more at the end as I’d like your opinion.</a:t>
             </a:r>
           </a:p>
           <a:p>
@@ -8745,6 +8645,12 @@
             <a:r>
               <a:rPr lang="en-GB" sz="2600" dirty="0"/>
               <a:t>Mobile Port / Accessibility Features</a:t>
+            </a:r>
+          </a:p>
+          <a:p>
+            <a:r>
+              <a:rPr lang="en-GB" sz="2600" dirty="0"/>
+              <a:t>Debugging &amp; Testing</a:t>
             </a:r>
           </a:p>
           <a:p>

</xml_diff>